<commit_message>
Add pricing/investment slide to Tu Asesor de Visa deck
New slide 16 breaks out the two independent investment lines: agency
management fees (launch price of 950.000 COP/mes for months 1-3, full
rate of 1.300.000 COP/mes from month 4 onward) and the recommended
minimum Meta Ads media budget of 1.500.000 COP/mes, kept explicitly
separate from the fees. Closing slide renumbered to 17.

Co-Authored-By: Claude Sonnet 5 <noreply@anthropic.com>
Claude-Session: https://claude.ai/code/session_01SmkHKcxHsRiRKSPUZSC2qb
</commit_message>
<xml_diff>
--- a/Rafael - Tu Asesor de Visa (Bogota)/Tu_Asesor_de_Visa_Meta_Ads.pptx
+++ b/Rafael - Tu Asesor de Visa (Bogota)/Tu_Asesor_de_Visa_Meta_Ads.pptx
@@ -21,9 +21,10 @@
     <p:sldId id="269" r:id="rId15"/>
     <p:sldId id="270" r:id="rId16"/>
     <p:sldId id="271" r:id="rId17"/>
+    <p:sldId id="272" r:id="rId18"/>
   </p:sldIdLst>
   <p:notesMasterIdLst>
-    <p:notesMasterId r:id="rId18"/>
+    <p:notesMasterId r:id="rId19"/>
   </p:notesMasterIdLst>
   <p:sldSz cx="12192000" cy="6858000"/>
   <p:notesSz cx="6858000" cy="12192000"/>
@@ -1145,9 +1146,9 @@
           <a:p>
             <a:r>
               <a:rPr lang="en-US" dirty="0"/>
-              <a:t>OBJETIVO: Cerrar con una propuesta de acción clara, sin sonar comercial.
-MENSAJE PRINCIPAL: El crecimiento no depende de más publicidad genérica; depende de darle estructura a la confianza que Rafael ya construyó en 10 años.
-QUÉ EXPLICAR: Los tres pasos siguientes son concretos y secuenciales. La siguiente conversación debe definir el alcance y el cronograma de implementación, comenzando en Bogotá.</a:t>
+              <a:t>OBJETIVO: Presentar con claridad las dos líneas de inversión necesarias para poner en marcha el sistema, sin mezclar honorarios de gestión con presupuesto publicitario.
+MENSAJE PRINCIPAL: Son dos inversiones independientes: unos honorarios de gestión estratégica y un presupuesto de pauta que pertenece siempre a Rafael.
+QUÉ EXPLICAR: Los honorarios de gestión inician en $950.000 mensuales durante los primeros 3 meses como precio de lanzamiento, y pasan a la tarifa full de $1.300.000 mensuales desde el mes 4. Aparte, el presupuesto mínimo recomendado de pauta en Meta Ads es de $1.500.000 mensuales, que se invierte directamente en la plataforma y no hace parte de los honorarios.</a:t>
             </a:r>
             <a:endParaRPr lang="en-US" dirty="0"/>
           </a:p>
@@ -1171,6 +1172,96 @@
             <a:fld id="{F7021451-1387-4CA6-816F-3879F97B5CBC}" type="slidenum">
               <a:rPr lang="en-US"/>
               <a:t>16</a:t>
+            </a:fld>
+            <a:endParaRPr lang="en-US"/>
+          </a:p>
+        </p:txBody>
+      </p:sp>
+    </p:spTree>
+    <p:extLst>
+      <p:ext uri="{BB962C8B-B14F-4D97-AF65-F5344CB8AC3E}">
+        <p14:creationId xmlns:p14="http://schemas.microsoft.com/office/powerpoint/2010/main" val="1024086991"/>
+      </p:ext>
+    </p:extLst>
+  </p:cSld>
+  <p:clrMapOvr>
+    <a:masterClrMapping/>
+  </p:clrMapOvr>
+</p:notes>
+</file>
+
+<file path=ppt/notesSlides/notesSlide17.xml><?xml version="1.0" encoding="utf-8"?>
+<p:notes xmlns:a="http://schemas.openxmlformats.org/drawingml/2006/main" xmlns:r="http://schemas.openxmlformats.org/officeDocument/2006/relationships" xmlns:p="http://schemas.openxmlformats.org/presentationml/2006/main">
+  <p:cSld>
+    <p:spTree>
+      <p:nvGrpSpPr>
+        <p:cNvPr id="1" name=""/>
+        <p:cNvGrpSpPr/>
+        <p:nvPr/>
+      </p:nvGrpSpPr>
+      <p:grpSpPr>
+        <a:xfrm>
+          <a:off x="0" y="0"/>
+          <a:ext cx="0" cy="0"/>
+          <a:chOff x="0" y="0"/>
+          <a:chExt cx="0" cy="0"/>
+        </a:xfrm>
+      </p:grpSpPr>
+      <p:sp>
+        <p:nvSpPr>
+          <p:cNvPr id="2" name="Slide Image Placeholder 1"/>
+          <p:cNvSpPr>
+            <a:spLocks noGrp="1" noRot="1" noChangeAspect="1"/>
+          </p:cNvSpPr>
+          <p:nvPr>
+            <p:ph type="sldImg"/>
+          </p:nvPr>
+        </p:nvSpPr>
+        <p:spPr/>
+      </p:sp>
+      <p:sp>
+        <p:nvSpPr>
+          <p:cNvPr id="3" name="Notes Placeholder 2"/>
+          <p:cNvSpPr>
+            <a:spLocks noGrp="1"/>
+          </p:cNvSpPr>
+          <p:nvPr>
+            <p:ph type="body" idx="1"/>
+          </p:nvPr>
+        </p:nvSpPr>
+        <p:spPr/>
+        <p:txBody>
+          <a:bodyPr/>
+          <a:lstStyle/>
+          <a:p>
+            <a:r>
+              <a:rPr lang="en-US" dirty="0"/>
+              <a:t>OBJETIVO: Cerrar con una propuesta de acción clara, sin sonar comercial.
+MENSAJE PRINCIPAL: El crecimiento no depende de más publicidad genérica; depende de darle estructura a la confianza que Rafael ya construyó en 10 años.
+QUÉ EXPLICAR: Los tres pasos siguientes son concretos y secuenciales. La siguiente conversación debe definir el alcance y el cronograma de implementación, comenzando en Bogotá.</a:t>
+            </a:r>
+            <a:endParaRPr lang="en-US" dirty="0"/>
+          </a:p>
+        </p:txBody>
+      </p:sp>
+      <p:sp>
+        <p:nvSpPr>
+          <p:cNvPr id="4" name="Slide Number Placeholder 3"/>
+          <p:cNvSpPr>
+            <a:spLocks noGrp="1"/>
+          </p:cNvSpPr>
+          <p:nvPr>
+            <p:ph type="sldNum" sz="quarter" idx="10"/>
+          </p:nvPr>
+        </p:nvSpPr>
+        <p:spPr/>
+        <p:txBody>
+          <a:bodyPr/>
+          <a:lstStyle/>
+          <a:p>
+            <a:fld id="{F7021451-1387-4CA6-816F-3879F97B5CBC}" type="slidenum">
+              <a:rPr lang="en-US"/>
+              <a:t>17</a:t>
             </a:fld>
             <a:endParaRPr lang="en-US"/>
           </a:p>
@@ -7333,6 +7424,748 @@
 <file path=ppt/slides/slide16.xml><?xml version="1.0" encoding="utf-8"?>
 <p:sld xmlns:a="http://schemas.openxmlformats.org/drawingml/2006/main" xmlns:r="http://schemas.openxmlformats.org/officeDocument/2006/relationships" xmlns:p="http://schemas.openxmlformats.org/presentationml/2006/main">
   <p:cSld name="Slide 16">
+    <p:spTree>
+      <p:nvGrpSpPr>
+        <p:cNvPr id="1" name=""/>
+        <p:cNvGrpSpPr/>
+        <p:nvPr/>
+      </p:nvGrpSpPr>
+      <p:grpSpPr>
+        <a:xfrm>
+          <a:off x="0" y="0"/>
+          <a:ext cx="0" cy="0"/>
+          <a:chOff x="0" y="0"/>
+          <a:chExt cx="0" cy="0"/>
+        </a:xfrm>
+      </p:grpSpPr>
+      <p:sp>
+        <p:nvSpPr>
+          <p:cNvPr id="2" name="Text 0"/>
+          <p:cNvSpPr/>
+          <p:nvPr/>
+        </p:nvSpPr>
+        <p:spPr>
+          <a:xfrm>
+            <a:off x="640080" y="502920"/>
+            <a:ext cx="9144000" cy="320040"/>
+          </a:xfrm>
+          <a:prstGeom prst="rect">
+            <a:avLst/>
+          </a:prstGeom>
+          <a:noFill/>
+          <a:ln/>
+        </p:spPr>
+        <p:txBody>
+          <a:bodyPr wrap="square" lIns="0" tIns="0" rIns="0" bIns="0" rtlCol="0" anchor="ctr"/>
+          <a:lstStyle/>
+          <a:p>
+            <a:pPr indent="0" marL="0">
+              <a:buNone/>
+            </a:pPr>
+            <a:r>
+              <a:rPr lang="en-US" sz="1200" b="1" spc="200" kern="0" dirty="0">
+                <a:solidFill>
+                  <a:srgbClr val="9C7A3C"/>
+                </a:solidFill>
+                <a:latin typeface="Calibri" pitchFamily="34" charset="0"/>
+                <a:ea typeface="Calibri" pitchFamily="34" charset="-122"/>
+                <a:cs typeface="Calibri" pitchFamily="34" charset="-120"/>
+              </a:rPr>
+              <a:t>LA INVERSIÓN</a:t>
+            </a:r>
+            <a:endParaRPr lang="en-US" sz="1200" dirty="0"/>
+          </a:p>
+        </p:txBody>
+      </p:sp>
+      <p:sp>
+        <p:nvSpPr>
+          <p:cNvPr id="3" name="Text 1"/>
+          <p:cNvSpPr/>
+          <p:nvPr/>
+        </p:nvSpPr>
+        <p:spPr>
+          <a:xfrm>
+            <a:off x="640080" y="841248"/>
+            <a:ext cx="10698480" cy="868680"/>
+          </a:xfrm>
+          <a:prstGeom prst="rect">
+            <a:avLst/>
+          </a:prstGeom>
+          <a:noFill/>
+          <a:ln/>
+        </p:spPr>
+        <p:txBody>
+          <a:bodyPr wrap="square" lIns="0" tIns="0" rIns="0" bIns="0" rtlCol="0" anchor="ctr"/>
+          <a:lstStyle/>
+          <a:p>
+            <a:pPr algn="l" indent="0" marL="0">
+              <a:buNone/>
+            </a:pPr>
+            <a:r>
+              <a:rPr lang="en-US" sz="3200" b="1" dirty="0">
+                <a:solidFill>
+                  <a:srgbClr val="121A2B"/>
+                </a:solidFill>
+                <a:latin typeface="Cambria" pitchFamily="34" charset="0"/>
+                <a:ea typeface="Cambria" pitchFamily="34" charset="-122"/>
+                <a:cs typeface="Cambria" pitchFamily="34" charset="-120"/>
+              </a:rPr>
+              <a:t>Lo que se necesita para activar el sistema</a:t>
+            </a:r>
+            <a:endParaRPr lang="en-US" sz="3200" dirty="0"/>
+          </a:p>
+        </p:txBody>
+      </p:sp>
+      <p:sp>
+        <p:nvSpPr>
+          <p:cNvPr id="4" name="Text 2"/>
+          <p:cNvSpPr/>
+          <p:nvPr/>
+        </p:nvSpPr>
+        <p:spPr>
+          <a:xfrm>
+            <a:off x="640080" y="1481328"/>
+            <a:ext cx="9601200" cy="365760"/>
+          </a:xfrm>
+          <a:prstGeom prst="rect">
+            <a:avLst/>
+          </a:prstGeom>
+          <a:noFill/>
+          <a:ln/>
+        </p:spPr>
+        <p:txBody>
+          <a:bodyPr wrap="square" lIns="0" tIns="0" rIns="0" bIns="0" rtlCol="0" anchor="ctr"/>
+          <a:lstStyle/>
+          <a:p>
+            <a:pPr indent="0" marL="0">
+              <a:buNone/>
+            </a:pPr>
+            <a:r>
+              <a:rPr lang="en-US" sz="1500" dirty="0">
+                <a:solidFill>
+                  <a:srgbClr val="6B6B66"/>
+                </a:solidFill>
+                <a:latin typeface="Calibri" pitchFamily="34" charset="0"/>
+                <a:ea typeface="Calibri" pitchFamily="34" charset="-122"/>
+                <a:cs typeface="Calibri" pitchFamily="34" charset="-120"/>
+              </a:rPr>
+              <a:t>Dos líneas de inversión, independientes entre sí.</a:t>
+            </a:r>
+            <a:endParaRPr lang="en-US" sz="1500" dirty="0"/>
+          </a:p>
+        </p:txBody>
+      </p:sp>
+      <p:sp>
+        <p:nvSpPr>
+          <p:cNvPr id="5" name="Shape 3"/>
+          <p:cNvSpPr/>
+          <p:nvPr/>
+        </p:nvSpPr>
+        <p:spPr>
+          <a:xfrm>
+            <a:off x="640080" y="2011680"/>
+            <a:ext cx="5074920" cy="3520440"/>
+          </a:xfrm>
+          <a:prstGeom prst="roundRect">
+            <a:avLst>
+              <a:gd name="adj" fmla="val 2078"/>
+            </a:avLst>
+          </a:prstGeom>
+          <a:solidFill>
+            <a:srgbClr val="F5F5F3"/>
+          </a:solidFill>
+          <a:ln/>
+        </p:spPr>
+      </p:sp>
+      <p:sp>
+        <p:nvSpPr>
+          <p:cNvPr id="6" name="Text 4"/>
+          <p:cNvSpPr/>
+          <p:nvPr/>
+        </p:nvSpPr>
+        <p:spPr>
+          <a:xfrm>
+            <a:off x="1005840" y="2304288"/>
+            <a:ext cx="4343400" cy="365760"/>
+          </a:xfrm>
+          <a:prstGeom prst="rect">
+            <a:avLst/>
+          </a:prstGeom>
+          <a:noFill/>
+          <a:ln/>
+        </p:spPr>
+        <p:txBody>
+          <a:bodyPr wrap="square" lIns="0" tIns="0" rIns="0" bIns="0" rtlCol="0" anchor="ctr"/>
+          <a:lstStyle/>
+          <a:p>
+            <a:pPr indent="0" marL="0">
+              <a:buNone/>
+            </a:pPr>
+            <a:r>
+              <a:rPr lang="en-US" sz="1250" b="1" spc="100" kern="0" dirty="0">
+                <a:solidFill>
+                  <a:srgbClr val="6B6B66"/>
+                </a:solidFill>
+                <a:latin typeface="Calibri" pitchFamily="34" charset="0"/>
+                <a:ea typeface="Calibri" pitchFamily="34" charset="-122"/>
+                <a:cs typeface="Calibri" pitchFamily="34" charset="-120"/>
+              </a:rPr>
+              <a:t>HONORARIOS DE GESTIÓN ESTRATÉGICA</a:t>
+            </a:r>
+            <a:endParaRPr lang="en-US" sz="1250" dirty="0"/>
+          </a:p>
+        </p:txBody>
+      </p:sp>
+      <p:sp>
+        <p:nvSpPr>
+          <p:cNvPr id="7" name="Text 5"/>
+          <p:cNvSpPr/>
+          <p:nvPr/>
+        </p:nvSpPr>
+        <p:spPr>
+          <a:xfrm>
+            <a:off x="1005840" y="2834640"/>
+            <a:ext cx="4343400" cy="274320"/>
+          </a:xfrm>
+          <a:prstGeom prst="rect">
+            <a:avLst/>
+          </a:prstGeom>
+          <a:noFill/>
+          <a:ln/>
+        </p:spPr>
+        <p:txBody>
+          <a:bodyPr wrap="square" lIns="0" tIns="0" rIns="0" bIns="0" rtlCol="0" anchor="ctr"/>
+          <a:lstStyle/>
+          <a:p>
+            <a:pPr indent="0" marL="0">
+              <a:buNone/>
+            </a:pPr>
+            <a:r>
+              <a:rPr lang="en-US" sz="1050" b="1" spc="50" kern="0" dirty="0">
+                <a:solidFill>
+                  <a:srgbClr val="9C7A3C"/>
+                </a:solidFill>
+                <a:latin typeface="Calibri" pitchFamily="34" charset="0"/>
+                <a:ea typeface="Calibri" pitchFamily="34" charset="-122"/>
+                <a:cs typeface="Calibri" pitchFamily="34" charset="-120"/>
+              </a:rPr>
+              <a:t>MESES 1 A 3 · PRECIO DE LANZAMIENTO</a:t>
+            </a:r>
+            <a:endParaRPr lang="en-US" sz="1050" dirty="0"/>
+          </a:p>
+        </p:txBody>
+      </p:sp>
+      <p:sp>
+        <p:nvSpPr>
+          <p:cNvPr id="8" name="Text 6"/>
+          <p:cNvSpPr/>
+          <p:nvPr/>
+        </p:nvSpPr>
+        <p:spPr>
+          <a:xfrm>
+            <a:off x="1005840" y="3108960"/>
+            <a:ext cx="4343400" cy="548640"/>
+          </a:xfrm>
+          <a:prstGeom prst="rect">
+            <a:avLst/>
+          </a:prstGeom>
+          <a:noFill/>
+          <a:ln/>
+        </p:spPr>
+        <p:txBody>
+          <a:bodyPr wrap="square" lIns="0" tIns="0" rIns="0" bIns="0" rtlCol="0" anchor="ctr"/>
+          <a:lstStyle/>
+          <a:p>
+            <a:pPr indent="0" marL="0">
+              <a:buNone/>
+            </a:pPr>
+            <a:r>
+              <a:rPr lang="en-US" sz="3400" b="1" dirty="0">
+                <a:solidFill>
+                  <a:srgbClr val="121A2B"/>
+                </a:solidFill>
+                <a:latin typeface="Cambria" pitchFamily="34" charset="0"/>
+                <a:ea typeface="Cambria" pitchFamily="34" charset="-122"/>
+                <a:cs typeface="Cambria" pitchFamily="34" charset="-120"/>
+              </a:rPr>
+              <a:t>$950.000</a:t>
+            </a:r>
+            <a:pPr indent="0" marL="0">
+              <a:buNone/>
+            </a:pPr>
+            <a:r>
+              <a:rPr lang="en-US" sz="1500" dirty="0">
+                <a:solidFill>
+                  <a:srgbClr val="6B6B66"/>
+                </a:solidFill>
+                <a:latin typeface="Cambria" pitchFamily="34" charset="0"/>
+                <a:ea typeface="Cambria" pitchFamily="34" charset="-122"/>
+                <a:cs typeface="Cambria" pitchFamily="34" charset="-120"/>
+              </a:rPr>
+              <a:t>  /mes</a:t>
+            </a:r>
+            <a:endParaRPr lang="en-US" sz="3400" dirty="0"/>
+          </a:p>
+        </p:txBody>
+      </p:sp>
+      <p:sp>
+        <p:nvSpPr>
+          <p:cNvPr id="9" name="Shape 7"/>
+          <p:cNvSpPr/>
+          <p:nvPr/>
+        </p:nvSpPr>
+        <p:spPr>
+          <a:xfrm>
+            <a:off x="1005840" y="3840480"/>
+            <a:ext cx="4343400" cy="0"/>
+          </a:xfrm>
+          <a:prstGeom prst="line">
+            <a:avLst/>
+          </a:prstGeom>
+          <a:noFill/>
+          <a:ln w="12700">
+            <a:solidFill>
+              <a:srgbClr val="E4E3DF"/>
+            </a:solidFill>
+            <a:prstDash val="solid"/>
+          </a:ln>
+        </p:spPr>
+      </p:sp>
+      <p:sp>
+        <p:nvSpPr>
+          <p:cNvPr id="10" name="Text 8"/>
+          <p:cNvSpPr/>
+          <p:nvPr/>
+        </p:nvSpPr>
+        <p:spPr>
+          <a:xfrm>
+            <a:off x="1005840" y="4005072"/>
+            <a:ext cx="4343400" cy="274320"/>
+          </a:xfrm>
+          <a:prstGeom prst="rect">
+            <a:avLst/>
+          </a:prstGeom>
+          <a:noFill/>
+          <a:ln/>
+        </p:spPr>
+        <p:txBody>
+          <a:bodyPr wrap="square" lIns="0" tIns="0" rIns="0" bIns="0" rtlCol="0" anchor="ctr"/>
+          <a:lstStyle/>
+          <a:p>
+            <a:pPr indent="0" marL="0">
+              <a:buNone/>
+            </a:pPr>
+            <a:r>
+              <a:rPr lang="en-US" sz="1050" b="1" spc="50" kern="0" dirty="0">
+                <a:solidFill>
+                  <a:srgbClr val="6B6B66"/>
+                </a:solidFill>
+                <a:latin typeface="Calibri" pitchFamily="34" charset="0"/>
+                <a:ea typeface="Calibri" pitchFamily="34" charset="-122"/>
+                <a:cs typeface="Calibri" pitchFamily="34" charset="-120"/>
+              </a:rPr>
+              <a:t>DESDE EL MES 4 · TARIFA FULL</a:t>
+            </a:r>
+            <a:endParaRPr lang="en-US" sz="1050" dirty="0"/>
+          </a:p>
+        </p:txBody>
+      </p:sp>
+      <p:sp>
+        <p:nvSpPr>
+          <p:cNvPr id="11" name="Text 9"/>
+          <p:cNvSpPr/>
+          <p:nvPr/>
+        </p:nvSpPr>
+        <p:spPr>
+          <a:xfrm>
+            <a:off x="1005840" y="4279392"/>
+            <a:ext cx="4343400" cy="548640"/>
+          </a:xfrm>
+          <a:prstGeom prst="rect">
+            <a:avLst/>
+          </a:prstGeom>
+          <a:noFill/>
+          <a:ln/>
+        </p:spPr>
+        <p:txBody>
+          <a:bodyPr wrap="square" lIns="0" tIns="0" rIns="0" bIns="0" rtlCol="0" anchor="ctr"/>
+          <a:lstStyle/>
+          <a:p>
+            <a:pPr indent="0" marL="0">
+              <a:buNone/>
+            </a:pPr>
+            <a:r>
+              <a:rPr lang="en-US" sz="3400" b="1" dirty="0">
+                <a:solidFill>
+                  <a:srgbClr val="121A2B"/>
+                </a:solidFill>
+                <a:latin typeface="Cambria" pitchFamily="34" charset="0"/>
+                <a:ea typeface="Cambria" pitchFamily="34" charset="-122"/>
+                <a:cs typeface="Cambria" pitchFamily="34" charset="-120"/>
+              </a:rPr>
+              <a:t>$1.300.000</a:t>
+            </a:r>
+            <a:pPr indent="0" marL="0">
+              <a:buNone/>
+            </a:pPr>
+            <a:r>
+              <a:rPr lang="en-US" sz="1500" dirty="0">
+                <a:solidFill>
+                  <a:srgbClr val="6B6B66"/>
+                </a:solidFill>
+                <a:latin typeface="Cambria" pitchFamily="34" charset="0"/>
+                <a:ea typeface="Cambria" pitchFamily="34" charset="-122"/>
+                <a:cs typeface="Cambria" pitchFamily="34" charset="-120"/>
+              </a:rPr>
+              <a:t>  /mes</a:t>
+            </a:r>
+            <a:endParaRPr lang="en-US" sz="3400" dirty="0"/>
+          </a:p>
+        </p:txBody>
+      </p:sp>
+      <p:sp>
+        <p:nvSpPr>
+          <p:cNvPr id="12" name="Text 10"/>
+          <p:cNvSpPr/>
+          <p:nvPr/>
+        </p:nvSpPr>
+        <p:spPr>
+          <a:xfrm>
+            <a:off x="1005840" y="4919472"/>
+            <a:ext cx="4343400" cy="548640"/>
+          </a:xfrm>
+          <a:prstGeom prst="rect">
+            <a:avLst/>
+          </a:prstGeom>
+          <a:noFill/>
+          <a:ln/>
+        </p:spPr>
+        <p:txBody>
+          <a:bodyPr wrap="square" lIns="0" tIns="0" rIns="0" bIns="0" rtlCol="0" anchor="ctr"/>
+          <a:lstStyle/>
+          <a:p>
+            <a:pPr indent="0" marL="0">
+              <a:buNone/>
+            </a:pPr>
+            <a:r>
+              <a:rPr lang="en-US" sz="1100" dirty="0">
+                <a:solidFill>
+                  <a:srgbClr val="6B6B66"/>
+                </a:solidFill>
+                <a:latin typeface="Calibri" pitchFamily="34" charset="0"/>
+                <a:ea typeface="Calibri" pitchFamily="34" charset="-122"/>
+                <a:cs typeface="Calibri" pitchFamily="34" charset="-120"/>
+              </a:rPr>
+              <a:t>Incluye estrategia, diseño de campañas, gestión y optimización continua de las 4 etapas del sistema.</a:t>
+            </a:r>
+            <a:endParaRPr lang="en-US" sz="1100" dirty="0"/>
+          </a:p>
+        </p:txBody>
+      </p:sp>
+      <p:sp>
+        <p:nvSpPr>
+          <p:cNvPr id="13" name="Shape 11"/>
+          <p:cNvSpPr/>
+          <p:nvPr/>
+        </p:nvSpPr>
+        <p:spPr>
+          <a:xfrm>
+            <a:off x="6172200" y="2011680"/>
+            <a:ext cx="5074920" cy="3520440"/>
+          </a:xfrm>
+          <a:prstGeom prst="roundRect">
+            <a:avLst>
+              <a:gd name="adj" fmla="val 2078"/>
+            </a:avLst>
+          </a:prstGeom>
+          <a:solidFill>
+            <a:srgbClr val="121A2B"/>
+          </a:solidFill>
+          <a:ln/>
+        </p:spPr>
+      </p:sp>
+      <p:sp>
+        <p:nvSpPr>
+          <p:cNvPr id="14" name="Text 12"/>
+          <p:cNvSpPr/>
+          <p:nvPr/>
+        </p:nvSpPr>
+        <p:spPr>
+          <a:xfrm>
+            <a:off x="6537960" y="2304288"/>
+            <a:ext cx="4343400" cy="365760"/>
+          </a:xfrm>
+          <a:prstGeom prst="rect">
+            <a:avLst/>
+          </a:prstGeom>
+          <a:noFill/>
+          <a:ln/>
+        </p:spPr>
+        <p:txBody>
+          <a:bodyPr wrap="square" lIns="0" tIns="0" rIns="0" bIns="0" rtlCol="0" anchor="ctr"/>
+          <a:lstStyle/>
+          <a:p>
+            <a:pPr indent="0" marL="0">
+              <a:buNone/>
+            </a:pPr>
+            <a:r>
+              <a:rPr lang="en-US" sz="1250" b="1" spc="100" kern="0" dirty="0">
+                <a:solidFill>
+                  <a:srgbClr val="C9A868"/>
+                </a:solidFill>
+                <a:latin typeface="Calibri" pitchFamily="34" charset="0"/>
+                <a:ea typeface="Calibri" pitchFamily="34" charset="-122"/>
+                <a:cs typeface="Calibri" pitchFamily="34" charset="-120"/>
+              </a:rPr>
+              <a:t>PRESUPUESTO DE PAUTA EN META ADS</a:t>
+            </a:r>
+            <a:endParaRPr lang="en-US" sz="1250" dirty="0"/>
+          </a:p>
+        </p:txBody>
+      </p:sp>
+      <p:sp>
+        <p:nvSpPr>
+          <p:cNvPr id="15" name="Text 13"/>
+          <p:cNvSpPr/>
+          <p:nvPr/>
+        </p:nvSpPr>
+        <p:spPr>
+          <a:xfrm>
+            <a:off x="6537960" y="2834640"/>
+            <a:ext cx="4343400" cy="274320"/>
+          </a:xfrm>
+          <a:prstGeom prst="rect">
+            <a:avLst/>
+          </a:prstGeom>
+          <a:noFill/>
+          <a:ln/>
+        </p:spPr>
+        <p:txBody>
+          <a:bodyPr wrap="square" lIns="0" tIns="0" rIns="0" bIns="0" rtlCol="0" anchor="ctr"/>
+          <a:lstStyle/>
+          <a:p>
+            <a:pPr indent="0" marL="0">
+              <a:buNone/>
+            </a:pPr>
+            <a:r>
+              <a:rPr lang="en-US" sz="1050" b="1" spc="50" kern="0" dirty="0">
+                <a:solidFill>
+                  <a:srgbClr val="B8B4AC"/>
+                </a:solidFill>
+                <a:latin typeface="Calibri" pitchFamily="34" charset="0"/>
+                <a:ea typeface="Calibri" pitchFamily="34" charset="-122"/>
+                <a:cs typeface="Calibri" pitchFamily="34" charset="-120"/>
+              </a:rPr>
+              <a:t>MÍNIMO RECOMENDADO</a:t>
+            </a:r>
+            <a:endParaRPr lang="en-US" sz="1050" dirty="0"/>
+          </a:p>
+        </p:txBody>
+      </p:sp>
+      <p:sp>
+        <p:nvSpPr>
+          <p:cNvPr id="16" name="Text 14"/>
+          <p:cNvSpPr/>
+          <p:nvPr/>
+        </p:nvSpPr>
+        <p:spPr>
+          <a:xfrm>
+            <a:off x="6537960" y="3108960"/>
+            <a:ext cx="4343400" cy="548640"/>
+          </a:xfrm>
+          <a:prstGeom prst="rect">
+            <a:avLst/>
+          </a:prstGeom>
+          <a:noFill/>
+          <a:ln/>
+        </p:spPr>
+        <p:txBody>
+          <a:bodyPr wrap="square" lIns="0" tIns="0" rIns="0" bIns="0" rtlCol="0" anchor="ctr"/>
+          <a:lstStyle/>
+          <a:p>
+            <a:pPr indent="0" marL="0">
+              <a:buNone/>
+            </a:pPr>
+            <a:r>
+              <a:rPr lang="en-US" sz="3400" b="1" dirty="0">
+                <a:solidFill>
+                  <a:srgbClr val="FFFFFF"/>
+                </a:solidFill>
+                <a:latin typeface="Cambria" pitchFamily="34" charset="0"/>
+                <a:ea typeface="Cambria" pitchFamily="34" charset="-122"/>
+                <a:cs typeface="Cambria" pitchFamily="34" charset="-120"/>
+              </a:rPr>
+              <a:t>$1.500.000</a:t>
+            </a:r>
+            <a:pPr indent="0" marL="0">
+              <a:buNone/>
+            </a:pPr>
+            <a:r>
+              <a:rPr lang="en-US" sz="1500" dirty="0">
+                <a:solidFill>
+                  <a:srgbClr val="B8B4AC"/>
+                </a:solidFill>
+                <a:latin typeface="Cambria" pitchFamily="34" charset="0"/>
+                <a:ea typeface="Cambria" pitchFamily="34" charset="-122"/>
+                <a:cs typeface="Cambria" pitchFamily="34" charset="-120"/>
+              </a:rPr>
+              <a:t>  /mes</a:t>
+            </a:r>
+            <a:endParaRPr lang="en-US" sz="3400" dirty="0"/>
+          </a:p>
+        </p:txBody>
+      </p:sp>
+      <p:sp>
+        <p:nvSpPr>
+          <p:cNvPr id="17" name="Shape 15"/>
+          <p:cNvSpPr/>
+          <p:nvPr/>
+        </p:nvSpPr>
+        <p:spPr>
+          <a:xfrm>
+            <a:off x="6537960" y="3840480"/>
+            <a:ext cx="4343400" cy="0"/>
+          </a:xfrm>
+          <a:prstGeom prst="line">
+            <a:avLst/>
+          </a:prstGeom>
+          <a:noFill/>
+          <a:ln w="12700">
+            <a:solidFill>
+              <a:srgbClr val="2A3654"/>
+            </a:solidFill>
+            <a:prstDash val="solid"/>
+          </a:ln>
+        </p:spPr>
+      </p:sp>
+      <p:sp>
+        <p:nvSpPr>
+          <p:cNvPr id="18" name="Text 16"/>
+          <p:cNvSpPr/>
+          <p:nvPr/>
+        </p:nvSpPr>
+        <p:spPr>
+          <a:xfrm>
+            <a:off x="6537960" y="3977640"/>
+            <a:ext cx="4343400" cy="1280160"/>
+          </a:xfrm>
+          <a:prstGeom prst="rect">
+            <a:avLst/>
+          </a:prstGeom>
+          <a:noFill/>
+          <a:ln/>
+        </p:spPr>
+        <p:txBody>
+          <a:bodyPr wrap="square" lIns="0" tIns="0" rIns="0" bIns="0" rtlCol="0" anchor="ctr"/>
+          <a:lstStyle/>
+          <a:p>
+            <a:pPr indent="0" marL="0">
+              <a:buNone/>
+            </a:pPr>
+            <a:r>
+              <a:rPr lang="en-US" sz="1200" dirty="0">
+                <a:solidFill>
+                  <a:srgbClr val="D3D2CE"/>
+                </a:solidFill>
+                <a:latin typeface="Calibri" pitchFamily="34" charset="0"/>
+                <a:ea typeface="Calibri" pitchFamily="34" charset="-122"/>
+                <a:cs typeface="Calibri" pitchFamily="34" charset="-120"/>
+              </a:rPr>
+              <a:t>Se invierte 100% en la plataforma de Meta. Financia el alcance, la evaluación, la conversión y la reactivación de clientes en las 4 etapas del sistema.</a:t>
+            </a:r>
+            <a:endParaRPr lang="en-US" sz="1200" dirty="0"/>
+          </a:p>
+        </p:txBody>
+      </p:sp>
+      <p:sp>
+        <p:nvSpPr>
+          <p:cNvPr id="19" name="Text 17"/>
+          <p:cNvSpPr/>
+          <p:nvPr/>
+        </p:nvSpPr>
+        <p:spPr>
+          <a:xfrm>
+            <a:off x="640080" y="5760720"/>
+            <a:ext cx="10881360" cy="457200"/>
+          </a:xfrm>
+          <a:prstGeom prst="rect">
+            <a:avLst/>
+          </a:prstGeom>
+          <a:noFill/>
+          <a:ln/>
+        </p:spPr>
+        <p:txBody>
+          <a:bodyPr wrap="square" lIns="0" tIns="0" rIns="0" bIns="0" rtlCol="0" anchor="ctr"/>
+          <a:lstStyle/>
+          <a:p>
+            <a:pPr indent="0" marL="0">
+              <a:buNone/>
+            </a:pPr>
+            <a:r>
+              <a:rPr lang="en-US" sz="1250" i="1" dirty="0">
+                <a:solidFill>
+                  <a:srgbClr val="121A2B"/>
+                </a:solidFill>
+                <a:latin typeface="Calibri" pitchFamily="34" charset="0"/>
+                <a:ea typeface="Calibri" pitchFamily="34" charset="-122"/>
+                <a:cs typeface="Calibri" pitchFamily="34" charset="-120"/>
+              </a:rPr>
+              <a:t>Los honorarios cubren la estrategia y la ejecución; el presupuesto de pauta pertenece 100% a Tu Asesor de Visa y se administra directamente dentro de la cuenta publicitaria.</a:t>
+            </a:r>
+            <a:endParaRPr lang="en-US" sz="1250" dirty="0"/>
+          </a:p>
+        </p:txBody>
+      </p:sp>
+      <p:sp>
+        <p:nvSpPr>
+          <p:cNvPr id="20" name="Text 18"/>
+          <p:cNvSpPr/>
+          <p:nvPr/>
+        </p:nvSpPr>
+        <p:spPr>
+          <a:xfrm>
+            <a:off x="11365992" y="6400800"/>
+            <a:ext cx="548640" cy="274320"/>
+          </a:xfrm>
+          <a:prstGeom prst="rect">
+            <a:avLst/>
+          </a:prstGeom>
+          <a:noFill/>
+          <a:ln/>
+        </p:spPr>
+        <p:txBody>
+          <a:bodyPr wrap="square" lIns="0" tIns="0" rIns="0" bIns="0" rtlCol="0" anchor="ctr"/>
+          <a:lstStyle/>
+          <a:p>
+            <a:pPr algn="r" indent="0" marL="0">
+              <a:buNone/>
+            </a:pPr>
+            <a:r>
+              <a:rPr lang="en-US" sz="1000" dirty="0">
+                <a:solidFill>
+                  <a:srgbClr val="6B6B66"/>
+                </a:solidFill>
+                <a:latin typeface="Calibri" pitchFamily="34" charset="0"/>
+                <a:ea typeface="Calibri" pitchFamily="34" charset="-122"/>
+                <a:cs typeface="Calibri" pitchFamily="34" charset="-120"/>
+              </a:rPr>
+              <a:t>16</a:t>
+            </a:r>
+            <a:endParaRPr lang="en-US" sz="1000" dirty="0"/>
+          </a:p>
+        </p:txBody>
+      </p:sp>
+    </p:spTree>
+  </p:cSld>
+  <p:clrMapOvr>
+    <a:masterClrMapping/>
+  </p:clrMapOvr>
+</p:sld>
+</file>
+
+<file path=ppt/slides/slide17.xml><?xml version="1.0" encoding="utf-8"?>
+<p:sld xmlns:a="http://schemas.openxmlformats.org/drawingml/2006/main" xmlns:r="http://schemas.openxmlformats.org/officeDocument/2006/relationships" xmlns:p="http://schemas.openxmlformats.org/presentationml/2006/main">
+  <p:cSld name="Slide 17">
     <p:bg>
       <p:bgPr>
         <a:solidFill>
@@ -7899,7 +8732,7 @@
                 <a:ea typeface="Calibri" pitchFamily="34" charset="-122"/>
                 <a:cs typeface="Calibri" pitchFamily="34" charset="-120"/>
               </a:rPr>
-              <a:t>16</a:t>
+              <a:t>17</a:t>
             </a:r>
             <a:endParaRPr lang="en-US" sz="1000" dirty="0"/>
           </a:p>

</xml_diff>